<commit_message>
Figure 3 PPT v3: Mt. Everest walk-through + validator → generation feedback loop
Each stage card now carries a concrete Mt. Everest example (sample → 9
variants → iterate to pass validators → 20 rows). Pink U-shaped
feedback arrow above ② and ③ shows the validator driving the generator
to rewrite the variant; the ③ example shows draft #1, #2 rejected and
#3 accepted.
</commit_message>
<xml_diff>
--- a/fig3_pipeline.pptx
+++ b/fig3_pipeline.pptx
@@ -3096,8 +3096,8 @@
         </p:nvSpPr>
         <p:spPr>
           <a:xfrm>
-            <a:off x="182880" y="182880"/>
-            <a:ext cx="11795760" cy="502920"/>
+            <a:off x="182880" y="137160"/>
+            <a:ext cx="11795760" cy="384048"/>
           </a:xfrm>
           <a:prstGeom prst="roundRect">
             <a:avLst/>
@@ -3131,7 +3131,7 @@
           <a:p>
             <a:pPr algn="ctr"/>
             <a:r>
-              <a:rPr sz="2200" b="1" i="0">
+              <a:rPr sz="1800" b="1" i="0">
                 <a:solidFill>
                   <a:srgbClr val="212529"/>
                 </a:solidFill>
@@ -3150,8 +3150,8 @@
         </p:nvSpPr>
         <p:spPr>
           <a:xfrm>
-            <a:off x="402336" y="914400"/>
-            <a:ext cx="2606040" cy="4937760"/>
+            <a:off x="256032" y="1143000"/>
+            <a:ext cx="2697480" cy="4846320"/>
           </a:xfrm>
           <a:prstGeom prst="roundRect">
             <a:avLst/>
@@ -3204,8 +3204,8 @@
         </p:nvSpPr>
         <p:spPr>
           <a:xfrm>
-            <a:off x="539496" y="1005840"/>
-            <a:ext cx="2331720" cy="411480"/>
+            <a:off x="365760" y="1216152"/>
+            <a:ext cx="2478024" cy="384048"/>
           </a:xfrm>
           <a:prstGeom prst="rect">
             <a:avLst/>
@@ -3220,7 +3220,7 @@
           <a:p>
             <a:pPr algn="ctr"/>
             <a:r>
-              <a:rPr sz="1700" b="1" i="0">
+              <a:rPr sz="1600" b="1" i="0">
                 <a:solidFill>
                   <a:srgbClr val="1971C2"/>
                 </a:solidFill>
@@ -3247,8 +3247,8 @@
         </p:blipFill>
         <p:spPr>
           <a:xfrm>
-            <a:off x="1065276" y="1554480"/>
-            <a:ext cx="1280160" cy="1280160"/>
+            <a:off x="420624" y="1673352"/>
+            <a:ext cx="868680" cy="868680"/>
           </a:xfrm>
           <a:prstGeom prst="rect">
             <a:avLst/>
@@ -3263,8 +3263,8 @@
         </p:nvSpPr>
         <p:spPr>
           <a:xfrm>
-            <a:off x="539496" y="3108960"/>
-            <a:ext cx="2331720" cy="457200"/>
+            <a:off x="1371600" y="1645920"/>
+            <a:ext cx="1453896" cy="320040"/>
           </a:xfrm>
           <a:prstGeom prst="rect">
             <a:avLst/>
@@ -3279,7 +3279,7 @@
           <a:p>
             <a:pPr algn="l"/>
             <a:r>
-              <a:rPr sz="1500" b="0" i="0">
+              <a:rPr sz="1200" b="0" i="0">
                 <a:solidFill>
                   <a:srgbClr val="212529"/>
                 </a:solidFill>
@@ -3298,8 +3298,8 @@
         </p:nvSpPr>
         <p:spPr>
           <a:xfrm>
-            <a:off x="539496" y="3611880"/>
-            <a:ext cx="2331720" cy="457200"/>
+            <a:off x="1371600" y="1965960"/>
+            <a:ext cx="1453896" cy="320040"/>
           </a:xfrm>
           <a:prstGeom prst="rect">
             <a:avLst/>
@@ -3314,7 +3314,7 @@
           <a:p>
             <a:pPr algn="l"/>
             <a:r>
-              <a:rPr sz="1500" b="0" i="0">
+              <a:rPr sz="1200" b="0" i="0">
                 <a:solidFill>
                   <a:srgbClr val="212529"/>
                 </a:solidFill>
@@ -3333,8 +3333,8 @@
         </p:nvSpPr>
         <p:spPr>
           <a:xfrm>
-            <a:off x="539496" y="4114800"/>
-            <a:ext cx="2331720" cy="457200"/>
+            <a:off x="1371600" y="2286000"/>
+            <a:ext cx="1453896" cy="320040"/>
           </a:xfrm>
           <a:prstGeom prst="rect">
             <a:avLst/>
@@ -3349,7 +3349,7 @@
           <a:p>
             <a:pPr algn="l"/>
             <a:r>
-              <a:rPr sz="1500" b="0" i="0">
+              <a:rPr sz="1200" b="0" i="0">
                 <a:solidFill>
                   <a:srgbClr val="212529"/>
                 </a:solidFill>
@@ -3368,8 +3368,8 @@
         </p:nvSpPr>
         <p:spPr>
           <a:xfrm>
-            <a:off x="585216" y="5074920"/>
-            <a:ext cx="2240280" cy="548640"/>
+            <a:off x="420624" y="2743200"/>
+            <a:ext cx="2368296" cy="274320"/>
           </a:xfrm>
           <a:prstGeom prst="roundRect">
             <a:avLst/>
@@ -3403,9 +3403,165 @@
           <a:p>
             <a:pPr algn="ctr"/>
             <a:r>
-              <a:rPr sz="1400" b="1" i="0">
+              <a:rPr sz="1000" b="1" i="1">
                 <a:solidFill>
                   <a:srgbClr val="1971C2"/>
+                </a:solidFill>
+                <a:latin typeface="Comic Sans MS"/>
+              </a:rPr>
+              <a:t>Wikidata (Mt. Everest, country, ?)</a:t>
+            </a:r>
+          </a:p>
+        </p:txBody>
+      </p:sp>
+      <p:sp>
+        <p:nvSpPr>
+          <p:cNvPr id="10" name="Rounded Rectangle 9"/>
+          <p:cNvSpPr/>
+          <p:nvPr/>
+        </p:nvSpPr>
+        <p:spPr>
+          <a:xfrm>
+            <a:off x="420624" y="3035808"/>
+            <a:ext cx="2368296" cy="2313432"/>
+          </a:xfrm>
+          <a:prstGeom prst="roundRect">
+            <a:avLst/>
+          </a:prstGeom>
+          <a:solidFill>
+            <a:srgbClr val="FFFFFF"/>
+          </a:solidFill>
+          <a:ln w="19050">
+            <a:solidFill>
+              <a:srgbClr val="1971C2"/>
+            </a:solidFill>
+          </a:ln>
+        </p:spPr>
+        <p:style>
+          <a:lnRef idx="1">
+            <a:schemeClr val="accent1"/>
+          </a:lnRef>
+          <a:fillRef idx="3">
+            <a:schemeClr val="accent1"/>
+          </a:fillRef>
+          <a:effectRef idx="2">
+            <a:schemeClr val="accent1"/>
+          </a:effectRef>
+          <a:fontRef idx="minor">
+            <a:schemeClr val="lt1"/>
+          </a:fontRef>
+        </p:style>
+        <p:txBody>
+          <a:bodyPr rtlCol="0" anchor="t" lIns="73152" rIns="73152" wrap="square"/>
+          <a:lstStyle/>
+          <a:p>
+            <a:pPr algn="l"/>
+            <a:r>
+              <a:rPr sz="1200" b="0" i="0">
+                <a:solidFill>
+                  <a:srgbClr val="212529"/>
+                </a:solidFill>
+                <a:latin typeface="Comic Sans MS"/>
+              </a:rPr>
+              <a:t>Original Q:</a:t>
+            </a:r>
+          </a:p>
+          <a:p>
+            <a:pPr algn="l"/>
+            <a:r>
+              <a:rPr sz="1200" b="0" i="0">
+                <a:solidFill>
+                  <a:srgbClr val="212529"/>
+                </a:solidFill>
+                <a:latin typeface="Comic Sans MS"/>
+              </a:rPr>
+              <a:t>"In which country is</a:t>
+            </a:r>
+          </a:p>
+          <a:p>
+            <a:pPr algn="l"/>
+            <a:r>
+              <a:rPr sz="1200" b="0" i="0">
+                <a:solidFill>
+                  <a:srgbClr val="212529"/>
+                </a:solidFill>
+                <a:latin typeface="Comic Sans MS"/>
+              </a:rPr>
+              <a:t>Mt. Everest?"</a:t>
+            </a:r>
+          </a:p>
+          <a:p>
+            <a:pPr algn="l"/>
+            <a:r>
+              <a:rPr sz="1200" b="0" i="0">
+                <a:solidFill>
+                  <a:srgbClr val="212529"/>
+                </a:solidFill>
+                <a:latin typeface="Comic Sans MS"/>
+              </a:rPr>
+              <a:t/>
+            </a:r>
+          </a:p>
+          <a:p>
+            <a:pPr algn="l"/>
+            <a:r>
+              <a:rPr sz="1200" b="0" i="0">
+                <a:solidFill>
+                  <a:srgbClr val="212529"/>
+                </a:solidFill>
+                <a:latin typeface="Comic Sans MS"/>
+              </a:rPr>
+              <a:t>Gold:  Nepal</a:t>
+            </a:r>
+          </a:p>
+        </p:txBody>
+      </p:sp>
+      <p:sp>
+        <p:nvSpPr>
+          <p:cNvPr id="11" name="Rounded Rectangle 10"/>
+          <p:cNvSpPr/>
+          <p:nvPr/>
+        </p:nvSpPr>
+        <p:spPr>
+          <a:xfrm>
+            <a:off x="420624" y="5422392"/>
+            <a:ext cx="2368296" cy="457200"/>
+          </a:xfrm>
+          <a:prstGeom prst="roundRect">
+            <a:avLst/>
+          </a:prstGeom>
+          <a:solidFill>
+            <a:srgbClr val="1971C2"/>
+          </a:solidFill>
+          <a:ln w="19050">
+            <a:solidFill>
+              <a:srgbClr val="1971C2"/>
+            </a:solidFill>
+          </a:ln>
+        </p:spPr>
+        <p:style>
+          <a:lnRef idx="1">
+            <a:schemeClr val="accent1"/>
+          </a:lnRef>
+          <a:fillRef idx="3">
+            <a:schemeClr val="accent1"/>
+          </a:fillRef>
+          <a:effectRef idx="2">
+            <a:schemeClr val="accent1"/>
+          </a:effectRef>
+          <a:fontRef idx="minor">
+            <a:schemeClr val="lt1"/>
+          </a:fontRef>
+        </p:style>
+        <p:txBody>
+          <a:bodyPr rtlCol="0" anchor="ctr" lIns="73152" rIns="73152" wrap="square"/>
+          <a:lstStyle/>
+          <a:p>
+            <a:pPr algn="ctr"/>
+            <a:r>
+              <a:rPr sz="1300" b="1" i="0">
+                <a:solidFill>
+                  <a:srgbClr val="FFFFFF"/>
                 </a:solidFill>
                 <a:latin typeface="Comic Sans MS"/>
               </a:rPr>
@@ -3416,14 +3572,14 @@
       </p:sp>
       <p:sp>
         <p:nvSpPr>
-          <p:cNvPr id="10" name="Rounded Rectangle 9"/>
+          <p:cNvPr id="12" name="Rounded Rectangle 11"/>
           <p:cNvSpPr/>
           <p:nvPr/>
         </p:nvSpPr>
         <p:spPr>
           <a:xfrm>
-            <a:off x="3328416" y="914400"/>
-            <a:ext cx="2606040" cy="4937760"/>
+            <a:off x="3145536" y="1143000"/>
+            <a:ext cx="2697480" cy="4846320"/>
           </a:xfrm>
           <a:prstGeom prst="roundRect">
             <a:avLst/>
@@ -3470,14 +3626,14 @@
       </p:sp>
       <p:sp>
         <p:nvSpPr>
-          <p:cNvPr id="11" name="TextBox 10"/>
+          <p:cNvPr id="13" name="TextBox 12"/>
           <p:cNvSpPr txBox="1"/>
           <p:nvPr/>
         </p:nvSpPr>
         <p:spPr>
           <a:xfrm>
-            <a:off x="3465576" y="1005840"/>
-            <a:ext cx="2331720" cy="411480"/>
+            <a:off x="3255264" y="1216152"/>
+            <a:ext cx="2478024" cy="384048"/>
           </a:xfrm>
           <a:prstGeom prst="rect">
             <a:avLst/>
@@ -3492,7 +3648,7 @@
           <a:p>
             <a:pPr algn="ctr"/>
             <a:r>
-              <a:rPr sz="1700" b="1" i="0">
+              <a:rPr sz="1600" b="1" i="0">
                 <a:solidFill>
                   <a:srgbClr val="7048E8"/>
                 </a:solidFill>
@@ -3505,7 +3661,7 @@
       </p:sp>
       <p:pic>
         <p:nvPicPr>
-          <p:cNvPr id="12" name="Picture 11" descr="p2_robot.png"/>
+          <p:cNvPr id="14" name="Picture 13" descr="p2_robot.png"/>
           <p:cNvPicPr>
             <a:picLocks noChangeAspect="1"/>
           </p:cNvPicPr>
@@ -3519,8 +3675,8 @@
         </p:blipFill>
         <p:spPr>
           <a:xfrm>
-            <a:off x="3991356" y="1554480"/>
-            <a:ext cx="1280160" cy="1280160"/>
+            <a:off x="3310128" y="1673352"/>
+            <a:ext cx="868680" cy="868680"/>
           </a:xfrm>
           <a:prstGeom prst="rect">
             <a:avLst/>
@@ -3529,14 +3685,14 @@
       </p:pic>
       <p:sp>
         <p:nvSpPr>
-          <p:cNvPr id="13" name="TextBox 12"/>
+          <p:cNvPr id="15" name="TextBox 14"/>
           <p:cNvSpPr txBox="1"/>
           <p:nvPr/>
         </p:nvSpPr>
         <p:spPr>
           <a:xfrm>
-            <a:off x="3465576" y="3108960"/>
-            <a:ext cx="2331720" cy="457200"/>
+            <a:off x="4261104" y="1645920"/>
+            <a:ext cx="1453896" cy="320040"/>
           </a:xfrm>
           <a:prstGeom prst="rect">
             <a:avLst/>
@@ -3551,7 +3707,7 @@
           <a:p>
             <a:pPr algn="l"/>
             <a:r>
-              <a:rPr sz="1500" b="0" i="0">
+              <a:rPr sz="1200" b="0" i="0">
                 <a:solidFill>
                   <a:srgbClr val="212529"/>
                 </a:solidFill>
@@ -3564,14 +3720,14 @@
       </p:sp>
       <p:sp>
         <p:nvSpPr>
-          <p:cNvPr id="14" name="TextBox 13"/>
+          <p:cNvPr id="16" name="TextBox 15"/>
           <p:cNvSpPr txBox="1"/>
           <p:nvPr/>
         </p:nvSpPr>
         <p:spPr>
           <a:xfrm>
-            <a:off x="3465576" y="3611880"/>
-            <a:ext cx="2331720" cy="457200"/>
+            <a:off x="4261104" y="1965960"/>
+            <a:ext cx="1453896" cy="320040"/>
           </a:xfrm>
           <a:prstGeom prst="rect">
             <a:avLst/>
@@ -3586,7 +3742,7 @@
           <a:p>
             <a:pPr algn="l"/>
             <a:r>
-              <a:rPr sz="1500" b="0" i="0">
+              <a:rPr sz="1200" b="0" i="0">
                 <a:solidFill>
                   <a:srgbClr val="212529"/>
                 </a:solidFill>
@@ -3599,14 +3755,14 @@
       </p:sp>
       <p:sp>
         <p:nvSpPr>
-          <p:cNvPr id="15" name="TextBox 14"/>
+          <p:cNvPr id="17" name="TextBox 16"/>
           <p:cNvSpPr txBox="1"/>
           <p:nvPr/>
         </p:nvSpPr>
         <p:spPr>
           <a:xfrm>
-            <a:off x="3465576" y="4114800"/>
-            <a:ext cx="2331720" cy="457200"/>
+            <a:off x="4261104" y="2286000"/>
+            <a:ext cx="1453896" cy="320040"/>
           </a:xfrm>
           <a:prstGeom prst="rect">
             <a:avLst/>
@@ -3621,7 +3777,7 @@
           <a:p>
             <a:pPr algn="l"/>
             <a:r>
-              <a:rPr sz="1500" b="0" i="0">
+              <a:rPr sz="1200" b="0" i="0">
                 <a:solidFill>
                   <a:srgbClr val="212529"/>
                 </a:solidFill>
@@ -3634,14 +3790,14 @@
       </p:sp>
       <p:sp>
         <p:nvSpPr>
-          <p:cNvPr id="16" name="Rounded Rectangle 15"/>
+          <p:cNvPr id="18" name="Rounded Rectangle 17"/>
           <p:cNvSpPr/>
           <p:nvPr/>
         </p:nvSpPr>
         <p:spPr>
           <a:xfrm>
-            <a:off x="3511296" y="5074920"/>
-            <a:ext cx="2240280" cy="548640"/>
+            <a:off x="3310128" y="2743200"/>
+            <a:ext cx="2368296" cy="274320"/>
           </a:xfrm>
           <a:prstGeom prst="roundRect">
             <a:avLst/>
@@ -3675,9 +3831,165 @@
           <a:p>
             <a:pPr algn="ctr"/>
             <a:r>
-              <a:rPr sz="1400" b="1" i="0">
+              <a:rPr sz="1000" b="1" i="1">
                 <a:solidFill>
                   <a:srgbClr val="7048E8"/>
+                </a:solidFill>
+                <a:latin typeface="Comic Sans MS"/>
+              </a:rPr>
+              <a:t>1 backbone → 9 variants</a:t>
+            </a:r>
+          </a:p>
+        </p:txBody>
+      </p:sp>
+      <p:sp>
+        <p:nvSpPr>
+          <p:cNvPr id="19" name="Rounded Rectangle 18"/>
+          <p:cNvSpPr/>
+          <p:nvPr/>
+        </p:nvSpPr>
+        <p:spPr>
+          <a:xfrm>
+            <a:off x="3310128" y="3035808"/>
+            <a:ext cx="2368296" cy="2313432"/>
+          </a:xfrm>
+          <a:prstGeom prst="roundRect">
+            <a:avLst/>
+          </a:prstGeom>
+          <a:solidFill>
+            <a:srgbClr val="FFFFFF"/>
+          </a:solidFill>
+          <a:ln w="19050">
+            <a:solidFill>
+              <a:srgbClr val="7048E8"/>
+            </a:solidFill>
+          </a:ln>
+        </p:spPr>
+        <p:style>
+          <a:lnRef idx="1">
+            <a:schemeClr val="accent1"/>
+          </a:lnRef>
+          <a:fillRef idx="3">
+            <a:schemeClr val="accent1"/>
+          </a:fillRef>
+          <a:effectRef idx="2">
+            <a:schemeClr val="accent1"/>
+          </a:effectRef>
+          <a:fontRef idx="minor">
+            <a:schemeClr val="lt1"/>
+          </a:fontRef>
+        </p:style>
+        <p:txBody>
+          <a:bodyPr rtlCol="0" anchor="t" lIns="73152" rIns="73152" wrap="square"/>
+          <a:lstStyle/>
+          <a:p>
+            <a:pPr algn="l"/>
+            <a:r>
+              <a:rPr sz="1200" b="0" i="0">
+                <a:solidFill>
+                  <a:srgbClr val="212529"/>
+                </a:solidFill>
+                <a:latin typeface="Comic Sans MS"/>
+              </a:rPr>
+              <a:t>K-P:  "Hint: Mt. Everest</a:t>
+            </a:r>
+          </a:p>
+          <a:p>
+            <a:pPr algn="l"/>
+            <a:r>
+              <a:rPr sz="1200" b="0" i="0">
+                <a:solidFill>
+                  <a:srgbClr val="212529"/>
+                </a:solidFill>
+                <a:latin typeface="Comic Sans MS"/>
+              </a:rPr>
+              <a:t>borders Tibet.  Country?"</a:t>
+            </a:r>
+          </a:p>
+          <a:p>
+            <a:pPr algn="l"/>
+            <a:r>
+              <a:rPr sz="1200" b="0" i="0">
+                <a:solidFill>
+                  <a:srgbClr val="212529"/>
+                </a:solidFill>
+                <a:latin typeface="Comic Sans MS"/>
+              </a:rPr>
+              <a:t/>
+            </a:r>
+          </a:p>
+          <a:p>
+            <a:pPr algn="l"/>
+            <a:r>
+              <a:rPr sz="1200" b="0" i="0">
+                <a:solidFill>
+                  <a:srgbClr val="212529"/>
+                </a:solidFill>
+                <a:latin typeface="Comic Sans MS"/>
+              </a:rPr>
+              <a:t>K-D:  "Some say Mt. Everest</a:t>
+            </a:r>
+          </a:p>
+          <a:p>
+            <a:pPr algn="l"/>
+            <a:r>
+              <a:rPr sz="1200" b="0" i="0">
+                <a:solidFill>
+                  <a:srgbClr val="212529"/>
+                </a:solidFill>
+                <a:latin typeface="Comic Sans MS"/>
+              </a:rPr>
+              <a:t>is in India.  Country?"</a:t>
+            </a:r>
+          </a:p>
+        </p:txBody>
+      </p:sp>
+      <p:sp>
+        <p:nvSpPr>
+          <p:cNvPr id="20" name="Rounded Rectangle 19"/>
+          <p:cNvSpPr/>
+          <p:nvPr/>
+        </p:nvSpPr>
+        <p:spPr>
+          <a:xfrm>
+            <a:off x="3310128" y="5422392"/>
+            <a:ext cx="2368296" cy="457200"/>
+          </a:xfrm>
+          <a:prstGeom prst="roundRect">
+            <a:avLst/>
+          </a:prstGeom>
+          <a:solidFill>
+            <a:srgbClr val="7048E8"/>
+          </a:solidFill>
+          <a:ln w="19050">
+            <a:solidFill>
+              <a:srgbClr val="7048E8"/>
+            </a:solidFill>
+          </a:ln>
+        </p:spPr>
+        <p:style>
+          <a:lnRef idx="1">
+            <a:schemeClr val="accent1"/>
+          </a:lnRef>
+          <a:fillRef idx="3">
+            <a:schemeClr val="accent1"/>
+          </a:fillRef>
+          <a:effectRef idx="2">
+            <a:schemeClr val="accent1"/>
+          </a:effectRef>
+          <a:fontRef idx="minor">
+            <a:schemeClr val="lt1"/>
+          </a:fontRef>
+        </p:style>
+        <p:txBody>
+          <a:bodyPr rtlCol="0" anchor="ctr" lIns="73152" rIns="73152" wrap="square"/>
+          <a:lstStyle/>
+          <a:p>
+            <a:pPr algn="ctr"/>
+            <a:r>
+              <a:rPr sz="1300" b="1" i="0">
+                <a:solidFill>
+                  <a:srgbClr val="FFFFFF"/>
                 </a:solidFill>
                 <a:latin typeface="Comic Sans MS"/>
               </a:rPr>
@@ -3688,14 +4000,14 @@
       </p:sp>
       <p:sp>
         <p:nvSpPr>
-          <p:cNvPr id="17" name="Rounded Rectangle 16"/>
+          <p:cNvPr id="21" name="Rounded Rectangle 20"/>
           <p:cNvSpPr/>
           <p:nvPr/>
         </p:nvSpPr>
         <p:spPr>
           <a:xfrm>
-            <a:off x="6254496" y="914400"/>
-            <a:ext cx="2606040" cy="4937760"/>
+            <a:off x="6035040" y="1143000"/>
+            <a:ext cx="2697480" cy="4846320"/>
           </a:xfrm>
           <a:prstGeom prst="roundRect">
             <a:avLst/>
@@ -3742,14 +4054,14 @@
       </p:sp>
       <p:sp>
         <p:nvSpPr>
-          <p:cNvPr id="18" name="TextBox 17"/>
+          <p:cNvPr id="22" name="TextBox 21"/>
           <p:cNvSpPr txBox="1"/>
           <p:nvPr/>
         </p:nvSpPr>
         <p:spPr>
           <a:xfrm>
-            <a:off x="6391656" y="1005840"/>
-            <a:ext cx="2331720" cy="411480"/>
+            <a:off x="6144768" y="1216152"/>
+            <a:ext cx="2478024" cy="384048"/>
           </a:xfrm>
           <a:prstGeom prst="rect">
             <a:avLst/>
@@ -3764,7 +4076,7 @@
           <a:p>
             <a:pPr algn="ctr"/>
             <a:r>
-              <a:rPr sz="1700" b="1" i="0">
+              <a:rPr sz="1600" b="1" i="0">
                 <a:solidFill>
                   <a:srgbClr val="E8590C"/>
                 </a:solidFill>
@@ -3777,7 +4089,7 @@
       </p:sp>
       <p:pic>
         <p:nvPicPr>
-          <p:cNvPr id="19" name="Picture 18" descr="p3_check.png"/>
+          <p:cNvPr id="23" name="Picture 22" descr="p3_check.png"/>
           <p:cNvPicPr>
             <a:picLocks noChangeAspect="1"/>
           </p:cNvPicPr>
@@ -3791,8 +4103,8 @@
         </p:blipFill>
         <p:spPr>
           <a:xfrm>
-            <a:off x="6917436" y="1554480"/>
-            <a:ext cx="1280160" cy="1280160"/>
+            <a:off x="6199632" y="1673352"/>
+            <a:ext cx="868680" cy="868680"/>
           </a:xfrm>
           <a:prstGeom prst="rect">
             <a:avLst/>
@@ -3801,14 +4113,14 @@
       </p:pic>
       <p:sp>
         <p:nvSpPr>
-          <p:cNvPr id="20" name="TextBox 19"/>
+          <p:cNvPr id="24" name="TextBox 23"/>
           <p:cNvSpPr txBox="1"/>
           <p:nvPr/>
         </p:nvSpPr>
         <p:spPr>
           <a:xfrm>
-            <a:off x="6391656" y="3108960"/>
-            <a:ext cx="2331720" cy="457200"/>
+            <a:off x="7150608" y="1645920"/>
+            <a:ext cx="1453896" cy="320040"/>
           </a:xfrm>
           <a:prstGeom prst="rect">
             <a:avLst/>
@@ -3823,7 +4135,7 @@
           <a:p>
             <a:pPr algn="l"/>
             <a:r>
-              <a:rPr sz="1500" b="0" i="0">
+              <a:rPr sz="1200" b="0" i="0">
                 <a:solidFill>
                   <a:srgbClr val="212529"/>
                 </a:solidFill>
@@ -3836,14 +4148,14 @@
       </p:sp>
       <p:sp>
         <p:nvSpPr>
-          <p:cNvPr id="21" name="TextBox 20"/>
+          <p:cNvPr id="25" name="TextBox 24"/>
           <p:cNvSpPr txBox="1"/>
           <p:nvPr/>
         </p:nvSpPr>
         <p:spPr>
           <a:xfrm>
-            <a:off x="6391656" y="3611880"/>
-            <a:ext cx="2331720" cy="457200"/>
+            <a:off x="7150608" y="1965960"/>
+            <a:ext cx="1453896" cy="320040"/>
           </a:xfrm>
           <a:prstGeom prst="rect">
             <a:avLst/>
@@ -3858,7 +4170,7 @@
           <a:p>
             <a:pPr algn="l"/>
             <a:r>
-              <a:rPr sz="1500" b="0" i="0">
+              <a:rPr sz="1200" b="0" i="0">
                 <a:solidFill>
                   <a:srgbClr val="212529"/>
                 </a:solidFill>
@@ -3871,14 +4183,14 @@
       </p:sp>
       <p:sp>
         <p:nvSpPr>
-          <p:cNvPr id="22" name="TextBox 21"/>
+          <p:cNvPr id="26" name="TextBox 25"/>
           <p:cNvSpPr txBox="1"/>
           <p:nvPr/>
         </p:nvSpPr>
         <p:spPr>
           <a:xfrm>
-            <a:off x="6391656" y="4114800"/>
-            <a:ext cx="2331720" cy="457200"/>
+            <a:off x="7150608" y="2286000"/>
+            <a:ext cx="1453896" cy="320040"/>
           </a:xfrm>
           <a:prstGeom prst="rect">
             <a:avLst/>
@@ -3893,7 +4205,7 @@
           <a:p>
             <a:pPr algn="l"/>
             <a:r>
-              <a:rPr sz="1500" b="0" i="0">
+              <a:rPr sz="1200" b="0" i="0">
                 <a:solidFill>
                   <a:srgbClr val="212529"/>
                 </a:solidFill>
@@ -3906,14 +4218,14 @@
       </p:sp>
       <p:sp>
         <p:nvSpPr>
-          <p:cNvPr id="23" name="Rounded Rectangle 22"/>
+          <p:cNvPr id="27" name="Rounded Rectangle 26"/>
           <p:cNvSpPr/>
           <p:nvPr/>
         </p:nvSpPr>
         <p:spPr>
           <a:xfrm>
-            <a:off x="6437376" y="5074920"/>
-            <a:ext cx="2240280" cy="548640"/>
+            <a:off x="6199632" y="2743200"/>
+            <a:ext cx="2368296" cy="274320"/>
           </a:xfrm>
           <a:prstGeom prst="roundRect">
             <a:avLst/>
@@ -3947,9 +4259,201 @@
           <a:p>
             <a:pPr algn="ctr"/>
             <a:r>
-              <a:rPr sz="1400" b="1" i="0">
+              <a:rPr sz="1000" b="1" i="1">
                 <a:solidFill>
                   <a:srgbClr val="E8590C"/>
+                </a:solidFill>
+                <a:latin typeface="Comic Sans MS"/>
+              </a:rPr>
+              <a:t>Iterate on the K-D variant</a:t>
+            </a:r>
+          </a:p>
+        </p:txBody>
+      </p:sp>
+      <p:sp>
+        <p:nvSpPr>
+          <p:cNvPr id="28" name="Rounded Rectangle 27"/>
+          <p:cNvSpPr/>
+          <p:nvPr/>
+        </p:nvSpPr>
+        <p:spPr>
+          <a:xfrm>
+            <a:off x="6199632" y="3035808"/>
+            <a:ext cx="2368296" cy="2313432"/>
+          </a:xfrm>
+          <a:prstGeom prst="roundRect">
+            <a:avLst/>
+          </a:prstGeom>
+          <a:solidFill>
+            <a:srgbClr val="FFFFFF"/>
+          </a:solidFill>
+          <a:ln w="19050">
+            <a:solidFill>
+              <a:srgbClr val="E8590C"/>
+            </a:solidFill>
+          </a:ln>
+        </p:spPr>
+        <p:style>
+          <a:lnRef idx="1">
+            <a:schemeClr val="accent1"/>
+          </a:lnRef>
+          <a:fillRef idx="3">
+            <a:schemeClr val="accent1"/>
+          </a:fillRef>
+          <a:effectRef idx="2">
+            <a:schemeClr val="accent1"/>
+          </a:effectRef>
+          <a:fontRef idx="minor">
+            <a:schemeClr val="lt1"/>
+          </a:fontRef>
+        </p:style>
+        <p:txBody>
+          <a:bodyPr rtlCol="0" anchor="t" lIns="73152" rIns="73152" wrap="square"/>
+          <a:lstStyle/>
+          <a:p>
+            <a:pPr algn="l"/>
+            <a:r>
+              <a:rPr sz="1200" b="0" i="0">
+                <a:solidFill>
+                  <a:srgbClr val="212529"/>
+                </a:solidFill>
+                <a:latin typeface="Comic Sans MS"/>
+              </a:rPr>
+              <a:t>✗  draft #1: "Nepal" leaked</a:t>
+            </a:r>
+          </a:p>
+          <a:p>
+            <a:pPr algn="l"/>
+            <a:r>
+              <a:rPr sz="1200" b="0" i="0">
+                <a:solidFill>
+                  <a:srgbClr val="212529"/>
+                </a:solidFill>
+                <a:latin typeface="Comic Sans MS"/>
+              </a:rPr>
+              <a:t>    → reject ↺ regenerate</a:t>
+            </a:r>
+          </a:p>
+          <a:p>
+            <a:pPr algn="l"/>
+            <a:r>
+              <a:rPr sz="1200" b="0" i="0">
+                <a:solidFill>
+                  <a:srgbClr val="212529"/>
+                </a:solidFill>
+                <a:latin typeface="Comic Sans MS"/>
+              </a:rPr>
+              <a:t/>
+            </a:r>
+          </a:p>
+          <a:p>
+            <a:pPr algn="l"/>
+            <a:r>
+              <a:rPr sz="1200" b="0" i="0">
+                <a:solidFill>
+                  <a:srgbClr val="212529"/>
+                </a:solidFill>
+                <a:latin typeface="Comic Sans MS"/>
+              </a:rPr>
+              <a:t>✗  draft #2: distractor not a country</a:t>
+            </a:r>
+          </a:p>
+          <a:p>
+            <a:pPr algn="l"/>
+            <a:r>
+              <a:rPr sz="1200" b="0" i="0">
+                <a:solidFill>
+                  <a:srgbClr val="212529"/>
+                </a:solidFill>
+                <a:latin typeface="Comic Sans MS"/>
+              </a:rPr>
+              <a:t>    → reject ↺ regenerate</a:t>
+            </a:r>
+          </a:p>
+          <a:p>
+            <a:pPr algn="l"/>
+            <a:r>
+              <a:rPr sz="1200" b="0" i="0">
+                <a:solidFill>
+                  <a:srgbClr val="212529"/>
+                </a:solidFill>
+                <a:latin typeface="Comic Sans MS"/>
+              </a:rPr>
+              <a:t/>
+            </a:r>
+          </a:p>
+          <a:p>
+            <a:pPr algn="l"/>
+            <a:r>
+              <a:rPr sz="1200" b="0" i="0">
+                <a:solidFill>
+                  <a:srgbClr val="212529"/>
+                </a:solidFill>
+                <a:latin typeface="Comic Sans MS"/>
+              </a:rPr>
+              <a:t>✓  draft #3: all 3 checks pass</a:t>
+            </a:r>
+          </a:p>
+          <a:p>
+            <a:pPr algn="l"/>
+            <a:r>
+              <a:rPr sz="1200" b="0" i="0">
+                <a:solidFill>
+                  <a:srgbClr val="212529"/>
+                </a:solidFill>
+                <a:latin typeface="Comic Sans MS"/>
+              </a:rPr>
+              <a:t>→  accepted</a:t>
+            </a:r>
+          </a:p>
+        </p:txBody>
+      </p:sp>
+      <p:sp>
+        <p:nvSpPr>
+          <p:cNvPr id="29" name="Rounded Rectangle 28"/>
+          <p:cNvSpPr/>
+          <p:nvPr/>
+        </p:nvSpPr>
+        <p:spPr>
+          <a:xfrm>
+            <a:off x="6199632" y="5422392"/>
+            <a:ext cx="2368296" cy="457200"/>
+          </a:xfrm>
+          <a:prstGeom prst="roundRect">
+            <a:avLst/>
+          </a:prstGeom>
+          <a:solidFill>
+            <a:srgbClr val="E8590C"/>
+          </a:solidFill>
+          <a:ln w="19050">
+            <a:solidFill>
+              <a:srgbClr val="E8590C"/>
+            </a:solidFill>
+          </a:ln>
+        </p:spPr>
+        <p:style>
+          <a:lnRef idx="1">
+            <a:schemeClr val="accent1"/>
+          </a:lnRef>
+          <a:fillRef idx="3">
+            <a:schemeClr val="accent1"/>
+          </a:fillRef>
+          <a:effectRef idx="2">
+            <a:schemeClr val="accent1"/>
+          </a:effectRef>
+          <a:fontRef idx="minor">
+            <a:schemeClr val="lt1"/>
+          </a:fontRef>
+        </p:style>
+        <p:txBody>
+          <a:bodyPr rtlCol="0" anchor="ctr" lIns="73152" rIns="73152" wrap="square"/>
+          <a:lstStyle/>
+          <a:p>
+            <a:pPr algn="ctr"/>
+            <a:r>
+              <a:rPr sz="1300" b="1" i="0">
+                <a:solidFill>
+                  <a:srgbClr val="FFFFFF"/>
                 </a:solidFill>
                 <a:latin typeface="Comic Sans MS"/>
               </a:rPr>
@@ -3960,14 +4464,14 @@
       </p:sp>
       <p:sp>
         <p:nvSpPr>
-          <p:cNvPr id="24" name="Rounded Rectangle 23"/>
+          <p:cNvPr id="30" name="Rounded Rectangle 29"/>
           <p:cNvSpPr/>
           <p:nvPr/>
         </p:nvSpPr>
         <p:spPr>
           <a:xfrm>
-            <a:off x="9180576" y="914400"/>
-            <a:ext cx="2606040" cy="4937760"/>
+            <a:off x="8924544" y="1143000"/>
+            <a:ext cx="2697480" cy="4846320"/>
           </a:xfrm>
           <a:prstGeom prst="roundRect">
             <a:avLst/>
@@ -4014,14 +4518,14 @@
       </p:sp>
       <p:sp>
         <p:nvSpPr>
-          <p:cNvPr id="25" name="TextBox 24"/>
+          <p:cNvPr id="31" name="TextBox 30"/>
           <p:cNvSpPr txBox="1"/>
           <p:nvPr/>
         </p:nvSpPr>
         <p:spPr>
           <a:xfrm>
-            <a:off x="9317736" y="1005840"/>
-            <a:ext cx="2331720" cy="411480"/>
+            <a:off x="9034272" y="1216152"/>
+            <a:ext cx="2478024" cy="384048"/>
           </a:xfrm>
           <a:prstGeom prst="rect">
             <a:avLst/>
@@ -4036,7 +4540,7 @@
           <a:p>
             <a:pPr algn="ctr"/>
             <a:r>
-              <a:rPr sz="1700" b="1" i="0">
+              <a:rPr sz="1600" b="1" i="0">
                 <a:solidFill>
                   <a:srgbClr val="2B8A3E"/>
                 </a:solidFill>
@@ -4049,7 +4553,7 @@
       </p:sp>
       <p:pic>
         <p:nvPicPr>
-          <p:cNvPr id="26" name="Picture 25" descr="p4_box.png"/>
+          <p:cNvPr id="32" name="Picture 31" descr="p4_box.png"/>
           <p:cNvPicPr>
             <a:picLocks noChangeAspect="1"/>
           </p:cNvPicPr>
@@ -4063,8 +4567,8 @@
         </p:blipFill>
         <p:spPr>
           <a:xfrm>
-            <a:off x="9843516" y="1554480"/>
-            <a:ext cx="1280160" cy="1280160"/>
+            <a:off x="9089136" y="1673352"/>
+            <a:ext cx="868680" cy="868680"/>
           </a:xfrm>
           <a:prstGeom prst="rect">
             <a:avLst/>
@@ -4073,14 +4577,14 @@
       </p:pic>
       <p:sp>
         <p:nvSpPr>
-          <p:cNvPr id="27" name="TextBox 26"/>
+          <p:cNvPr id="33" name="TextBox 32"/>
           <p:cNvSpPr txBox="1"/>
           <p:nvPr/>
         </p:nvSpPr>
         <p:spPr>
           <a:xfrm>
-            <a:off x="9317736" y="3108960"/>
-            <a:ext cx="2331720" cy="457200"/>
+            <a:off x="10040112" y="1645920"/>
+            <a:ext cx="1453896" cy="320040"/>
           </a:xfrm>
           <a:prstGeom prst="rect">
             <a:avLst/>
@@ -4095,7 +4599,7 @@
           <a:p>
             <a:pPr algn="l"/>
             <a:r>
-              <a:rPr sz="1500" b="0" i="0">
+              <a:rPr sz="1200" b="0" i="0">
                 <a:solidFill>
                   <a:srgbClr val="212529"/>
                 </a:solidFill>
@@ -4108,14 +4612,14 @@
       </p:sp>
       <p:sp>
         <p:nvSpPr>
-          <p:cNvPr id="28" name="TextBox 27"/>
+          <p:cNvPr id="34" name="TextBox 33"/>
           <p:cNvSpPr txBox="1"/>
           <p:nvPr/>
         </p:nvSpPr>
         <p:spPr>
           <a:xfrm>
-            <a:off x="9317736" y="3611880"/>
-            <a:ext cx="2331720" cy="457200"/>
+            <a:off x="10040112" y="1965960"/>
+            <a:ext cx="1453896" cy="320040"/>
           </a:xfrm>
           <a:prstGeom prst="rect">
             <a:avLst/>
@@ -4130,7 +4634,7 @@
           <a:p>
             <a:pPr algn="l"/>
             <a:r>
-              <a:rPr sz="1500" b="0" i="0">
+              <a:rPr sz="1200" b="0" i="0">
                 <a:solidFill>
                   <a:srgbClr val="212529"/>
                 </a:solidFill>
@@ -4143,14 +4647,14 @@
       </p:sp>
       <p:sp>
         <p:nvSpPr>
-          <p:cNvPr id="29" name="TextBox 28"/>
+          <p:cNvPr id="35" name="TextBox 34"/>
           <p:cNvSpPr txBox="1"/>
           <p:nvPr/>
         </p:nvSpPr>
         <p:spPr>
           <a:xfrm>
-            <a:off x="9317736" y="4114800"/>
-            <a:ext cx="2331720" cy="457200"/>
+            <a:off x="10040112" y="2286000"/>
+            <a:ext cx="1453896" cy="320040"/>
           </a:xfrm>
           <a:prstGeom prst="rect">
             <a:avLst/>
@@ -4165,7 +4669,7 @@
           <a:p>
             <a:pPr algn="l"/>
             <a:r>
-              <a:rPr sz="1500" b="0" i="0">
+              <a:rPr sz="1200" b="0" i="0">
                 <a:solidFill>
                   <a:srgbClr val="212529"/>
                 </a:solidFill>
@@ -4178,14 +4682,14 @@
       </p:sp>
       <p:sp>
         <p:nvSpPr>
-          <p:cNvPr id="30" name="Rounded Rectangle 29"/>
+          <p:cNvPr id="36" name="Rounded Rectangle 35"/>
           <p:cNvSpPr/>
           <p:nvPr/>
         </p:nvSpPr>
         <p:spPr>
           <a:xfrm>
-            <a:off x="9363456" y="5074920"/>
-            <a:ext cx="2240280" cy="548640"/>
+            <a:off x="9089136" y="2743200"/>
+            <a:ext cx="2368296" cy="274320"/>
           </a:xfrm>
           <a:prstGeom prst="roundRect">
             <a:avLst/>
@@ -4219,9 +4723,165 @@
           <a:p>
             <a:pPr algn="ctr"/>
             <a:r>
-              <a:rPr sz="1400" b="1" i="0">
+              <a:rPr sz="1000" b="1" i="1">
                 <a:solidFill>
                   <a:srgbClr val="2B8A3E"/>
+                </a:solidFill>
+                <a:latin typeface="Comic Sans MS"/>
+              </a:rPr>
+              <a:t>This item contributes</a:t>
+            </a:r>
+          </a:p>
+        </p:txBody>
+      </p:sp>
+      <p:sp>
+        <p:nvSpPr>
+          <p:cNvPr id="37" name="Rounded Rectangle 36"/>
+          <p:cNvSpPr/>
+          <p:nvPr/>
+        </p:nvSpPr>
+        <p:spPr>
+          <a:xfrm>
+            <a:off x="9089136" y="3035808"/>
+            <a:ext cx="2368296" cy="2313432"/>
+          </a:xfrm>
+          <a:prstGeom prst="roundRect">
+            <a:avLst/>
+          </a:prstGeom>
+          <a:solidFill>
+            <a:srgbClr val="FFFFFF"/>
+          </a:solidFill>
+          <a:ln w="19050">
+            <a:solidFill>
+              <a:srgbClr val="2B8A3E"/>
+            </a:solidFill>
+          </a:ln>
+        </p:spPr>
+        <p:style>
+          <a:lnRef idx="1">
+            <a:schemeClr val="accent1"/>
+          </a:lnRef>
+          <a:fillRef idx="3">
+            <a:schemeClr val="accent1"/>
+          </a:fillRef>
+          <a:effectRef idx="2">
+            <a:schemeClr val="accent1"/>
+          </a:effectRef>
+          <a:fontRef idx="minor">
+            <a:schemeClr val="lt1"/>
+          </a:fontRef>
+        </p:style>
+        <p:txBody>
+          <a:bodyPr rtlCol="0" anchor="t" lIns="73152" rIns="73152" wrap="square"/>
+          <a:lstStyle/>
+          <a:p>
+            <a:pPr algn="l"/>
+            <a:r>
+              <a:rPr sz="1200" b="0" i="0">
+                <a:solidFill>
+                  <a:srgbClr val="212529"/>
+                </a:solidFill>
+                <a:latin typeface="Comic Sans MS"/>
+              </a:rPr>
+              <a:t>1 original  +  9 variants</a:t>
+            </a:r>
+          </a:p>
+          <a:p>
+            <a:pPr algn="l"/>
+            <a:r>
+              <a:rPr sz="1200" b="0" i="0">
+                <a:solidFill>
+                  <a:srgbClr val="212529"/>
+                </a:solidFill>
+                <a:latin typeface="Comic Sans MS"/>
+              </a:rPr>
+              <a:t>  × 2 surface modes</a:t>
+            </a:r>
+          </a:p>
+          <a:p>
+            <a:pPr algn="l"/>
+            <a:r>
+              <a:rPr sz="1200" b="0" i="0">
+                <a:solidFill>
+                  <a:srgbClr val="212529"/>
+                </a:solidFill>
+                <a:latin typeface="Comic Sans MS"/>
+              </a:rPr>
+              <a:t/>
+            </a:r>
+          </a:p>
+          <a:p>
+            <a:pPr algn="l"/>
+            <a:r>
+              <a:rPr sz="1200" b="0" i="0">
+                <a:solidFill>
+                  <a:srgbClr val="212529"/>
+                </a:solidFill>
+                <a:latin typeface="Comic Sans MS"/>
+              </a:rPr>
+              <a:t>= 20 rows for Mt. Everest</a:t>
+            </a:r>
+          </a:p>
+          <a:p>
+            <a:pPr algn="l"/>
+            <a:r>
+              <a:rPr sz="1200" b="0" i="0">
+                <a:solidFill>
+                  <a:srgbClr val="212529"/>
+                </a:solidFill>
+                <a:latin typeface="Comic Sans MS"/>
+              </a:rPr>
+              <a:t>   (1 of 75 backbones)</a:t>
+            </a:r>
+          </a:p>
+        </p:txBody>
+      </p:sp>
+      <p:sp>
+        <p:nvSpPr>
+          <p:cNvPr id="38" name="Rounded Rectangle 37"/>
+          <p:cNvSpPr/>
+          <p:nvPr/>
+        </p:nvSpPr>
+        <p:spPr>
+          <a:xfrm>
+            <a:off x="9089136" y="5422392"/>
+            <a:ext cx="2368296" cy="457200"/>
+          </a:xfrm>
+          <a:prstGeom prst="roundRect">
+            <a:avLst/>
+          </a:prstGeom>
+          <a:solidFill>
+            <a:srgbClr val="2B8A3E"/>
+          </a:solidFill>
+          <a:ln w="19050">
+            <a:solidFill>
+              <a:srgbClr val="2B8A3E"/>
+            </a:solidFill>
+          </a:ln>
+        </p:spPr>
+        <p:style>
+          <a:lnRef idx="1">
+            <a:schemeClr val="accent1"/>
+          </a:lnRef>
+          <a:fillRef idx="3">
+            <a:schemeClr val="accent1"/>
+          </a:fillRef>
+          <a:effectRef idx="2">
+            <a:schemeClr val="accent1"/>
+          </a:effectRef>
+          <a:fontRef idx="minor">
+            <a:schemeClr val="lt1"/>
+          </a:fontRef>
+        </p:style>
+        <p:txBody>
+          <a:bodyPr rtlCol="0" anchor="ctr" lIns="73152" rIns="73152" wrap="square"/>
+          <a:lstStyle/>
+          <a:p>
+            <a:pPr algn="ctr"/>
+            <a:r>
+              <a:rPr sz="1300" b="1" i="0">
+                <a:solidFill>
+                  <a:srgbClr val="FFFFFF"/>
                 </a:solidFill>
                 <a:latin typeface="Comic Sans MS"/>
               </a:rPr>
@@ -4232,19 +4892,19 @@
       </p:sp>
       <p:cxnSp>
         <p:nvCxnSpPr>
-          <p:cNvPr id="31" name="Connector 30"/>
+          <p:cNvPr id="39" name="Connector 38"/>
           <p:cNvCxnSpPr/>
           <p:nvPr/>
         </p:nvCxnSpPr>
         <p:spPr>
           <a:xfrm>
-            <a:off x="3026664" y="3383280"/>
-            <a:ext cx="283464" cy="0"/>
+            <a:off x="2962656" y="4069080"/>
+            <a:ext cx="173736" cy="0"/>
           </a:xfrm>
           <a:prstGeom prst="bentConnector3">
             <a:avLst/>
           </a:prstGeom>
-          <a:ln w="44450">
+          <a:ln w="50800">
             <a:solidFill>
               <a:srgbClr val="212529"/>
             </a:solidFill>
@@ -4268,19 +4928,19 @@
       </p:cxnSp>
       <p:cxnSp>
         <p:nvCxnSpPr>
-          <p:cNvPr id="32" name="Connector 31"/>
+          <p:cNvPr id="40" name="Connector 39"/>
           <p:cNvCxnSpPr/>
           <p:nvPr/>
         </p:nvCxnSpPr>
         <p:spPr>
           <a:xfrm>
-            <a:off x="5952744" y="3383280"/>
-            <a:ext cx="283463" cy="0"/>
+            <a:off x="5852160" y="4069080"/>
+            <a:ext cx="173736" cy="0"/>
           </a:xfrm>
           <a:prstGeom prst="bentConnector3">
             <a:avLst/>
           </a:prstGeom>
-          <a:ln w="44450">
+          <a:ln w="50800">
             <a:solidFill>
               <a:srgbClr val="212529"/>
             </a:solidFill>
@@ -4304,19 +4964,19 @@
       </p:cxnSp>
       <p:cxnSp>
         <p:nvCxnSpPr>
-          <p:cNvPr id="33" name="Connector 32"/>
+          <p:cNvPr id="41" name="Connector 40"/>
           <p:cNvCxnSpPr/>
           <p:nvPr/>
         </p:nvCxnSpPr>
         <p:spPr>
           <a:xfrm>
-            <a:off x="8878824" y="3383280"/>
-            <a:ext cx="283464" cy="0"/>
+            <a:off x="8741664" y="4069080"/>
+            <a:ext cx="173736" cy="0"/>
           </a:xfrm>
           <a:prstGeom prst="bentConnector3">
             <a:avLst/>
           </a:prstGeom>
-          <a:ln w="44450">
+          <a:ln w="50800">
             <a:solidFill>
               <a:srgbClr val="212529"/>
             </a:solidFill>
@@ -4338,16 +4998,227 @@
           </a:fontRef>
         </p:style>
       </p:cxnSp>
-      <p:sp>
-        <p:nvSpPr>
-          <p:cNvPr id="34" name="Rounded Rectangle 33"/>
+      <p:cxnSp>
+        <p:nvCxnSpPr>
+          <p:cNvPr id="42" name="Connector 41"/>
+          <p:cNvCxnSpPr/>
+          <p:nvPr/>
+        </p:nvCxnSpPr>
+        <p:spPr>
+          <a:xfrm flipV="1">
+            <a:off x="7383780" y="640080"/>
+            <a:ext cx="0" cy="502920"/>
+          </a:xfrm>
+          <a:prstGeom prst="line">
+            <a:avLst/>
+          </a:prstGeom>
+          <a:ln w="57150">
+            <a:solidFill>
+              <a:srgbClr val="D6336C"/>
+            </a:solidFill>
+          </a:ln>
+        </p:spPr>
+        <p:style>
+          <a:lnRef idx="2">
+            <a:schemeClr val="accent1"/>
+          </a:lnRef>
+          <a:fillRef idx="0">
+            <a:schemeClr val="accent1"/>
+          </a:fillRef>
+          <a:effectRef idx="1">
+            <a:schemeClr val="accent1"/>
+          </a:effectRef>
+          <a:fontRef idx="minor">
+            <a:schemeClr val="tx1"/>
+          </a:fontRef>
+        </p:style>
+      </p:cxnSp>
+      <p:cxnSp>
+        <p:nvCxnSpPr>
+          <p:cNvPr id="43" name="Connector 42"/>
+          <p:cNvCxnSpPr/>
+          <p:nvPr/>
+        </p:nvCxnSpPr>
+        <p:spPr>
+          <a:xfrm flipH="1">
+            <a:off x="4494276" y="640080"/>
+            <a:ext cx="2889504" cy="0"/>
+          </a:xfrm>
+          <a:prstGeom prst="line">
+            <a:avLst/>
+          </a:prstGeom>
+          <a:ln w="57150">
+            <a:solidFill>
+              <a:srgbClr val="D6336C"/>
+            </a:solidFill>
+          </a:ln>
+        </p:spPr>
+        <p:style>
+          <a:lnRef idx="2">
+            <a:schemeClr val="accent1"/>
+          </a:lnRef>
+          <a:fillRef idx="0">
+            <a:schemeClr val="accent1"/>
+          </a:fillRef>
+          <a:effectRef idx="1">
+            <a:schemeClr val="accent1"/>
+          </a:effectRef>
+          <a:fontRef idx="minor">
+            <a:schemeClr val="tx1"/>
+          </a:fontRef>
+        </p:style>
+      </p:cxnSp>
+      <p:cxnSp>
+        <p:nvCxnSpPr>
+          <p:cNvPr id="44" name="Connector 43"/>
+          <p:cNvCxnSpPr/>
+          <p:nvPr/>
+        </p:nvCxnSpPr>
+        <p:spPr>
+          <a:xfrm>
+            <a:off x="4494276" y="640080"/>
+            <a:ext cx="0" cy="502920"/>
+          </a:xfrm>
+          <a:prstGeom prst="line">
+            <a:avLst/>
+          </a:prstGeom>
+          <a:ln w="57150">
+            <a:solidFill>
+              <a:srgbClr val="D6336C"/>
+            </a:solidFill>
+            <a:tailEnd type="triangle" w="lg" len="lg"/>
+          </a:ln>
+        </p:spPr>
+        <p:style>
+          <a:lnRef idx="2">
+            <a:schemeClr val="accent1"/>
+          </a:lnRef>
+          <a:fillRef idx="0">
+            <a:schemeClr val="accent1"/>
+          </a:fillRef>
+          <a:effectRef idx="1">
+            <a:schemeClr val="accent1"/>
+          </a:effectRef>
+          <a:fontRef idx="minor">
+            <a:schemeClr val="tx1"/>
+          </a:fontRef>
+        </p:style>
+      </p:cxnSp>
+      <p:sp>
+        <p:nvSpPr>
+          <p:cNvPr id="45" name="TextBox 44"/>
+          <p:cNvSpPr txBox="1"/>
+          <p:nvPr/>
+        </p:nvSpPr>
+        <p:spPr>
+          <a:xfrm>
+            <a:off x="3561588" y="228599"/>
+            <a:ext cx="4754880" cy="292608"/>
+          </a:xfrm>
+          <a:prstGeom prst="rect">
+            <a:avLst/>
+          </a:prstGeom>
+          <a:noFill/>
+        </p:spPr>
+        <p:txBody>
+          <a:bodyPr wrap="square">
+            <a:spAutoFit/>
+          </a:bodyPr>
+          <a:lstStyle/>
+          <a:p>
+            <a:pPr algn="ctr"/>
+            <a:r>
+              <a:rPr sz="1300" b="1" i="1">
+                <a:solidFill>
+                  <a:srgbClr val="D6336C"/>
+                </a:solidFill>
+                <a:latin typeface="Comic Sans MS"/>
+              </a:rPr>
+              <a:t>↺  validator → generation:  keep rewriting the variant until it passes</a:t>
+            </a:r>
+          </a:p>
+        </p:txBody>
+      </p:sp>
+      <p:sp>
+        <p:nvSpPr>
+          <p:cNvPr id="46" name="TextBox 45"/>
+          <p:cNvSpPr txBox="1"/>
+          <p:nvPr/>
+        </p:nvSpPr>
+        <p:spPr>
+          <a:xfrm>
+            <a:off x="7018020" y="868680"/>
+            <a:ext cx="731520" cy="228600"/>
+          </a:xfrm>
+          <a:prstGeom prst="rect">
+            <a:avLst/>
+          </a:prstGeom>
+          <a:noFill/>
+        </p:spPr>
+        <p:txBody>
+          <a:bodyPr wrap="square">
+            <a:spAutoFit/>
+          </a:bodyPr>
+          <a:lstStyle/>
+          <a:p>
+            <a:pPr algn="ctr"/>
+            <a:r>
+              <a:rPr sz="1100" b="1" i="0">
+                <a:solidFill>
+                  <a:srgbClr val="D6336C"/>
+                </a:solidFill>
+                <a:latin typeface="Comic Sans MS"/>
+              </a:rPr>
+              <a:t>fail</a:t>
+            </a:r>
+          </a:p>
+        </p:txBody>
+      </p:sp>
+      <p:sp>
+        <p:nvSpPr>
+          <p:cNvPr id="47" name="TextBox 46"/>
+          <p:cNvSpPr txBox="1"/>
+          <p:nvPr/>
+        </p:nvSpPr>
+        <p:spPr>
+          <a:xfrm>
+            <a:off x="4037076" y="868680"/>
+            <a:ext cx="914400" cy="228600"/>
+          </a:xfrm>
+          <a:prstGeom prst="rect">
+            <a:avLst/>
+          </a:prstGeom>
+          <a:noFill/>
+        </p:spPr>
+        <p:txBody>
+          <a:bodyPr wrap="square">
+            <a:spAutoFit/>
+          </a:bodyPr>
+          <a:lstStyle/>
+          <a:p>
+            <a:pPr algn="ctr"/>
+            <a:r>
+              <a:rPr sz="1100" b="1" i="0">
+                <a:solidFill>
+                  <a:srgbClr val="D6336C"/>
+                </a:solidFill>
+                <a:latin typeface="Comic Sans MS"/>
+              </a:rPr>
+              <a:t>regen</a:t>
+            </a:r>
+          </a:p>
+        </p:txBody>
+      </p:sp>
+      <p:sp>
+        <p:nvSpPr>
+          <p:cNvPr id="48" name="Rounded Rectangle 47"/>
           <p:cNvSpPr/>
           <p:nvPr/>
         </p:nvSpPr>
         <p:spPr>
           <a:xfrm>
-            <a:off x="182880" y="6080760"/>
-            <a:ext cx="11795760" cy="594360"/>
+            <a:off x="182880" y="6172200"/>
+            <a:ext cx="11795760" cy="502920"/>
           </a:xfrm>
           <a:prstGeom prst="roundRect">
             <a:avLst/>
@@ -4381,13 +5252,13 @@
           <a:p>
             <a:pPr algn="ctr"/>
             <a:r>
-              <a:rPr sz="1700" b="1" i="1">
+              <a:rPr sz="1400" b="1" i="1">
                 <a:solidFill>
                   <a:srgbClr val="212529"/>
                 </a:solidFill>
                 <a:latin typeface="Comic Sans MS"/>
               </a:rPr>
-              <a:t>Same scaffold across K / R / C  →  one paired (original, variant) assay per capacity per backbone.</a:t>
+              <a:t>One backbone → 9 capacity variants → validated (with retry loop) → 20 dataset rows.   75 backbones × this pipeline = 650 rows.</a:t>
             </a:r>
           </a:p>
         </p:txBody>

</xml_diff>

<commit_message>
Figure 3 PPT v4: feedback loop sits between ② and ③, no more title-bar overlap
- Move retry arrow from above the cards into the gap between ② and ③
  (one short pink arrow ③→② just below the forward navy arrow).
- Restore full-size title bar.
- Tighten card whitespace: example box anchor middle, taller card.
</commit_message>
<xml_diff>
--- a/fig3_pipeline.pptx
+++ b/fig3_pipeline.pptx
@@ -3096,8 +3096,8 @@
         </p:nvSpPr>
         <p:spPr>
           <a:xfrm>
-            <a:off x="182880" y="137160"/>
-            <a:ext cx="11795760" cy="384048"/>
+            <a:off x="182880" y="182880"/>
+            <a:ext cx="11795760" cy="502920"/>
           </a:xfrm>
           <a:prstGeom prst="roundRect">
             <a:avLst/>
@@ -3131,7 +3131,7 @@
           <a:p>
             <a:pPr algn="ctr"/>
             <a:r>
-              <a:rPr sz="1800" b="1" i="0">
+              <a:rPr sz="2200" b="1" i="0">
                 <a:solidFill>
                   <a:srgbClr val="212529"/>
                 </a:solidFill>
@@ -3150,8 +3150,8 @@
         </p:nvSpPr>
         <p:spPr>
           <a:xfrm>
-            <a:off x="256032" y="1143000"/>
-            <a:ext cx="2697480" cy="4846320"/>
+            <a:off x="246888" y="822960"/>
+            <a:ext cx="2560320" cy="5166360"/>
           </a:xfrm>
           <a:prstGeom prst="roundRect">
             <a:avLst/>
@@ -3204,8 +3204,8 @@
         </p:nvSpPr>
         <p:spPr>
           <a:xfrm>
-            <a:off x="365760" y="1216152"/>
-            <a:ext cx="2478024" cy="384048"/>
+            <a:off x="356616" y="896112"/>
+            <a:ext cx="2340863" cy="384048"/>
           </a:xfrm>
           <a:prstGeom prst="rect">
             <a:avLst/>
@@ -3247,7 +3247,7 @@
         </p:blipFill>
         <p:spPr>
           <a:xfrm>
-            <a:off x="420624" y="1673352"/>
+            <a:off x="411480" y="1353312"/>
             <a:ext cx="868680" cy="868680"/>
           </a:xfrm>
           <a:prstGeom prst="rect">
@@ -3263,8 +3263,8 @@
         </p:nvSpPr>
         <p:spPr>
           <a:xfrm>
-            <a:off x="1371600" y="1645920"/>
-            <a:ext cx="1453896" cy="320040"/>
+            <a:off x="1362456" y="1325880"/>
+            <a:ext cx="1316735" cy="320040"/>
           </a:xfrm>
           <a:prstGeom prst="rect">
             <a:avLst/>
@@ -3298,8 +3298,8 @@
         </p:nvSpPr>
         <p:spPr>
           <a:xfrm>
-            <a:off x="1371600" y="1965960"/>
-            <a:ext cx="1453896" cy="320040"/>
+            <a:off x="1362456" y="1645920"/>
+            <a:ext cx="1316735" cy="320040"/>
           </a:xfrm>
           <a:prstGeom prst="rect">
             <a:avLst/>
@@ -3333,8 +3333,8 @@
         </p:nvSpPr>
         <p:spPr>
           <a:xfrm>
-            <a:off x="1371600" y="2286000"/>
-            <a:ext cx="1453896" cy="320040"/>
+            <a:off x="1362456" y="1965960"/>
+            <a:ext cx="1316735" cy="320040"/>
           </a:xfrm>
           <a:prstGeom prst="rect">
             <a:avLst/>
@@ -3368,8 +3368,8 @@
         </p:nvSpPr>
         <p:spPr>
           <a:xfrm>
-            <a:off x="420624" y="2743200"/>
-            <a:ext cx="2368296" cy="274320"/>
+            <a:off x="411480" y="2331720"/>
+            <a:ext cx="2231136" cy="274320"/>
           </a:xfrm>
           <a:prstGeom prst="roundRect">
             <a:avLst/>
@@ -3422,8 +3422,8 @@
         </p:nvSpPr>
         <p:spPr>
           <a:xfrm>
-            <a:off x="420624" y="3035808"/>
-            <a:ext cx="2368296" cy="2313432"/>
+            <a:off x="411480" y="2624327"/>
+            <a:ext cx="2231136" cy="2496312"/>
           </a:xfrm>
           <a:prstGeom prst="roundRect">
             <a:avLst/>
@@ -3452,7 +3452,7 @@
           </a:fontRef>
         </p:style>
         <p:txBody>
-          <a:bodyPr rtlCol="0" anchor="t" lIns="73152" rIns="73152" wrap="square"/>
+          <a:bodyPr rtlCol="0" anchor="ctr" lIns="73152" rIns="73152" wrap="square"/>
           <a:lstStyle/>
           <a:p>
             <a:pPr algn="l"/>
@@ -3524,8 +3524,8 @@
         </p:nvSpPr>
         <p:spPr>
           <a:xfrm>
-            <a:off x="420624" y="5422392"/>
-            <a:ext cx="2368296" cy="457200"/>
+            <a:off x="411480" y="5422392"/>
+            <a:ext cx="2231136" cy="457200"/>
           </a:xfrm>
           <a:prstGeom prst="roundRect">
             <a:avLst/>
@@ -3578,8 +3578,8 @@
         </p:nvSpPr>
         <p:spPr>
           <a:xfrm>
-            <a:off x="3145536" y="1143000"/>
-            <a:ext cx="2697480" cy="4846320"/>
+            <a:off x="3264408" y="822960"/>
+            <a:ext cx="2560320" cy="5166360"/>
           </a:xfrm>
           <a:prstGeom prst="roundRect">
             <a:avLst/>
@@ -3632,8 +3632,8 @@
         </p:nvSpPr>
         <p:spPr>
           <a:xfrm>
-            <a:off x="3255264" y="1216152"/>
-            <a:ext cx="2478024" cy="384048"/>
+            <a:off x="3374136" y="896112"/>
+            <a:ext cx="2340863" cy="384048"/>
           </a:xfrm>
           <a:prstGeom prst="rect">
             <a:avLst/>
@@ -3675,7 +3675,7 @@
         </p:blipFill>
         <p:spPr>
           <a:xfrm>
-            <a:off x="3310128" y="1673352"/>
+            <a:off x="3429000" y="1353312"/>
             <a:ext cx="868680" cy="868680"/>
           </a:xfrm>
           <a:prstGeom prst="rect">
@@ -3691,8 +3691,8 @@
         </p:nvSpPr>
         <p:spPr>
           <a:xfrm>
-            <a:off x="4261104" y="1645920"/>
-            <a:ext cx="1453896" cy="320040"/>
+            <a:off x="4379976" y="1325880"/>
+            <a:ext cx="1316735" cy="320040"/>
           </a:xfrm>
           <a:prstGeom prst="rect">
             <a:avLst/>
@@ -3726,8 +3726,8 @@
         </p:nvSpPr>
         <p:spPr>
           <a:xfrm>
-            <a:off x="4261104" y="1965960"/>
-            <a:ext cx="1453896" cy="320040"/>
+            <a:off x="4379976" y="1645920"/>
+            <a:ext cx="1316735" cy="320040"/>
           </a:xfrm>
           <a:prstGeom prst="rect">
             <a:avLst/>
@@ -3761,8 +3761,8 @@
         </p:nvSpPr>
         <p:spPr>
           <a:xfrm>
-            <a:off x="4261104" y="2286000"/>
-            <a:ext cx="1453896" cy="320040"/>
+            <a:off x="4379976" y="1965960"/>
+            <a:ext cx="1316735" cy="320040"/>
           </a:xfrm>
           <a:prstGeom prst="rect">
             <a:avLst/>
@@ -3796,8 +3796,8 @@
         </p:nvSpPr>
         <p:spPr>
           <a:xfrm>
-            <a:off x="3310128" y="2743200"/>
-            <a:ext cx="2368296" cy="274320"/>
+            <a:off x="3429000" y="2331720"/>
+            <a:ext cx="2231136" cy="274320"/>
           </a:xfrm>
           <a:prstGeom prst="roundRect">
             <a:avLst/>
@@ -3850,8 +3850,8 @@
         </p:nvSpPr>
         <p:spPr>
           <a:xfrm>
-            <a:off x="3310128" y="3035808"/>
-            <a:ext cx="2368296" cy="2313432"/>
+            <a:off x="3429000" y="2624327"/>
+            <a:ext cx="2231136" cy="2496312"/>
           </a:xfrm>
           <a:prstGeom prst="roundRect">
             <a:avLst/>
@@ -3880,7 +3880,7 @@
           </a:fontRef>
         </p:style>
         <p:txBody>
-          <a:bodyPr rtlCol="0" anchor="t" lIns="73152" rIns="73152" wrap="square"/>
+          <a:bodyPr rtlCol="0" anchor="ctr" lIns="73152" rIns="73152" wrap="square"/>
           <a:lstStyle/>
           <a:p>
             <a:pPr algn="l"/>
@@ -3952,8 +3952,8 @@
         </p:nvSpPr>
         <p:spPr>
           <a:xfrm>
-            <a:off x="3310128" y="5422392"/>
-            <a:ext cx="2368296" cy="457200"/>
+            <a:off x="3429000" y="5422392"/>
+            <a:ext cx="2231136" cy="457200"/>
           </a:xfrm>
           <a:prstGeom prst="roundRect">
             <a:avLst/>
@@ -4006,8 +4006,8 @@
         </p:nvSpPr>
         <p:spPr>
           <a:xfrm>
-            <a:off x="6035040" y="1143000"/>
-            <a:ext cx="2697480" cy="4846320"/>
+            <a:off x="6281927" y="822960"/>
+            <a:ext cx="2560320" cy="5166360"/>
           </a:xfrm>
           <a:prstGeom prst="roundRect">
             <a:avLst/>
@@ -4060,8 +4060,8 @@
         </p:nvSpPr>
         <p:spPr>
           <a:xfrm>
-            <a:off x="6144768" y="1216152"/>
-            <a:ext cx="2478024" cy="384048"/>
+            <a:off x="6391655" y="896112"/>
+            <a:ext cx="2340863" cy="384048"/>
           </a:xfrm>
           <a:prstGeom prst="rect">
             <a:avLst/>
@@ -4103,7 +4103,7 @@
         </p:blipFill>
         <p:spPr>
           <a:xfrm>
-            <a:off x="6199632" y="1673352"/>
+            <a:off x="6446519" y="1353312"/>
             <a:ext cx="868680" cy="868680"/>
           </a:xfrm>
           <a:prstGeom prst="rect">
@@ -4119,8 +4119,8 @@
         </p:nvSpPr>
         <p:spPr>
           <a:xfrm>
-            <a:off x="7150608" y="1645920"/>
-            <a:ext cx="1453896" cy="320040"/>
+            <a:off x="7397496" y="1325880"/>
+            <a:ext cx="1316735" cy="320040"/>
           </a:xfrm>
           <a:prstGeom prst="rect">
             <a:avLst/>
@@ -4154,8 +4154,8 @@
         </p:nvSpPr>
         <p:spPr>
           <a:xfrm>
-            <a:off x="7150608" y="1965960"/>
-            <a:ext cx="1453896" cy="320040"/>
+            <a:off x="7397496" y="1645920"/>
+            <a:ext cx="1316735" cy="320040"/>
           </a:xfrm>
           <a:prstGeom prst="rect">
             <a:avLst/>
@@ -4189,8 +4189,8 @@
         </p:nvSpPr>
         <p:spPr>
           <a:xfrm>
-            <a:off x="7150608" y="2286000"/>
-            <a:ext cx="1453896" cy="320040"/>
+            <a:off x="7397496" y="1965960"/>
+            <a:ext cx="1316735" cy="320040"/>
           </a:xfrm>
           <a:prstGeom prst="rect">
             <a:avLst/>
@@ -4224,8 +4224,8 @@
         </p:nvSpPr>
         <p:spPr>
           <a:xfrm>
-            <a:off x="6199632" y="2743200"/>
-            <a:ext cx="2368296" cy="274320"/>
+            <a:off x="6446519" y="2331720"/>
+            <a:ext cx="2231136" cy="274320"/>
           </a:xfrm>
           <a:prstGeom prst="roundRect">
             <a:avLst/>
@@ -4278,8 +4278,8 @@
         </p:nvSpPr>
         <p:spPr>
           <a:xfrm>
-            <a:off x="6199632" y="3035808"/>
-            <a:ext cx="2368296" cy="2313432"/>
+            <a:off x="6446519" y="2624327"/>
+            <a:ext cx="2231136" cy="2496312"/>
           </a:xfrm>
           <a:prstGeom prst="roundRect">
             <a:avLst/>
@@ -4308,7 +4308,7 @@
           </a:fontRef>
         </p:style>
         <p:txBody>
-          <a:bodyPr rtlCol="0" anchor="t" lIns="73152" rIns="73152" wrap="square"/>
+          <a:bodyPr rtlCol="0" anchor="ctr" lIns="73152" rIns="73152" wrap="square"/>
           <a:lstStyle/>
           <a:p>
             <a:pPr algn="l"/>
@@ -4416,8 +4416,8 @@
         </p:nvSpPr>
         <p:spPr>
           <a:xfrm>
-            <a:off x="6199632" y="5422392"/>
-            <a:ext cx="2368296" cy="457200"/>
+            <a:off x="6446519" y="5422392"/>
+            <a:ext cx="2231136" cy="457200"/>
           </a:xfrm>
           <a:prstGeom prst="roundRect">
             <a:avLst/>
@@ -4470,8 +4470,8 @@
         </p:nvSpPr>
         <p:spPr>
           <a:xfrm>
-            <a:off x="8924544" y="1143000"/>
-            <a:ext cx="2697480" cy="4846320"/>
+            <a:off x="9299447" y="822960"/>
+            <a:ext cx="2560320" cy="5166360"/>
           </a:xfrm>
           <a:prstGeom prst="roundRect">
             <a:avLst/>
@@ -4524,8 +4524,8 @@
         </p:nvSpPr>
         <p:spPr>
           <a:xfrm>
-            <a:off x="9034272" y="1216152"/>
-            <a:ext cx="2478024" cy="384048"/>
+            <a:off x="9409175" y="896112"/>
+            <a:ext cx="2340863" cy="384048"/>
           </a:xfrm>
           <a:prstGeom prst="rect">
             <a:avLst/>
@@ -4567,7 +4567,7 @@
         </p:blipFill>
         <p:spPr>
           <a:xfrm>
-            <a:off x="9089136" y="1673352"/>
+            <a:off x="9464039" y="1353312"/>
             <a:ext cx="868680" cy="868680"/>
           </a:xfrm>
           <a:prstGeom prst="rect">
@@ -4583,8 +4583,8 @@
         </p:nvSpPr>
         <p:spPr>
           <a:xfrm>
-            <a:off x="10040112" y="1645920"/>
-            <a:ext cx="1453896" cy="320040"/>
+            <a:off x="10415015" y="1325880"/>
+            <a:ext cx="1316735" cy="320040"/>
           </a:xfrm>
           <a:prstGeom prst="rect">
             <a:avLst/>
@@ -4618,8 +4618,8 @@
         </p:nvSpPr>
         <p:spPr>
           <a:xfrm>
-            <a:off x="10040112" y="1965960"/>
-            <a:ext cx="1453896" cy="320040"/>
+            <a:off x="10415015" y="1645920"/>
+            <a:ext cx="1316735" cy="320040"/>
           </a:xfrm>
           <a:prstGeom prst="rect">
             <a:avLst/>
@@ -4653,8 +4653,8 @@
         </p:nvSpPr>
         <p:spPr>
           <a:xfrm>
-            <a:off x="10040112" y="2286000"/>
-            <a:ext cx="1453896" cy="320040"/>
+            <a:off x="10415015" y="1965960"/>
+            <a:ext cx="1316735" cy="320040"/>
           </a:xfrm>
           <a:prstGeom prst="rect">
             <a:avLst/>
@@ -4688,8 +4688,8 @@
         </p:nvSpPr>
         <p:spPr>
           <a:xfrm>
-            <a:off x="9089136" y="2743200"/>
-            <a:ext cx="2368296" cy="274320"/>
+            <a:off x="9464039" y="2331720"/>
+            <a:ext cx="2231136" cy="274320"/>
           </a:xfrm>
           <a:prstGeom prst="roundRect">
             <a:avLst/>
@@ -4742,8 +4742,8 @@
         </p:nvSpPr>
         <p:spPr>
           <a:xfrm>
-            <a:off x="9089136" y="3035808"/>
-            <a:ext cx="2368296" cy="2313432"/>
+            <a:off x="9464039" y="2624327"/>
+            <a:ext cx="2231136" cy="2496312"/>
           </a:xfrm>
           <a:prstGeom prst="roundRect">
             <a:avLst/>
@@ -4772,7 +4772,7 @@
           </a:fontRef>
         </p:style>
         <p:txBody>
-          <a:bodyPr rtlCol="0" anchor="t" lIns="73152" rIns="73152" wrap="square"/>
+          <a:bodyPr rtlCol="0" anchor="ctr" lIns="73152" rIns="73152" wrap="square"/>
           <a:lstStyle/>
           <a:p>
             <a:pPr algn="l"/>
@@ -4844,8 +4844,8 @@
         </p:nvSpPr>
         <p:spPr>
           <a:xfrm>
-            <a:off x="9089136" y="5422392"/>
-            <a:ext cx="2368296" cy="457200"/>
+            <a:off x="9464039" y="5422392"/>
+            <a:ext cx="2231136" cy="457200"/>
           </a:xfrm>
           <a:prstGeom prst="roundRect">
             <a:avLst/>
@@ -4898,8 +4898,8 @@
         </p:nvCxnSpPr>
         <p:spPr>
           <a:xfrm>
-            <a:off x="2962656" y="4069080"/>
-            <a:ext cx="173736" cy="0"/>
+            <a:off x="2816351" y="3200400"/>
+            <a:ext cx="438912" cy="0"/>
           </a:xfrm>
           <a:prstGeom prst="bentConnector3">
             <a:avLst/>
@@ -4934,8 +4934,8 @@
         </p:nvCxnSpPr>
         <p:spPr>
           <a:xfrm>
-            <a:off x="5852160" y="4069080"/>
-            <a:ext cx="173736" cy="0"/>
+            <a:off x="5833871" y="3200400"/>
+            <a:ext cx="438912" cy="0"/>
           </a:xfrm>
           <a:prstGeom prst="bentConnector3">
             <a:avLst/>
@@ -4970,8 +4970,8 @@
         </p:nvCxnSpPr>
         <p:spPr>
           <a:xfrm>
-            <a:off x="8741664" y="4069080"/>
-            <a:ext cx="173736" cy="0"/>
+            <a:off x="8851391" y="3200400"/>
+            <a:ext cx="438912" cy="0"/>
           </a:xfrm>
           <a:prstGeom prst="bentConnector3">
             <a:avLst/>
@@ -5005,17 +5005,18 @@
           <p:nvPr/>
         </p:nvCxnSpPr>
         <p:spPr>
-          <a:xfrm flipV="1">
-            <a:off x="7383780" y="640080"/>
-            <a:ext cx="0" cy="502920"/>
+          <a:xfrm flipH="1">
+            <a:off x="5843015" y="4754880"/>
+            <a:ext cx="420625" cy="0"/>
           </a:xfrm>
           <a:prstGeom prst="line">
             <a:avLst/>
           </a:prstGeom>
-          <a:ln w="57150">
+          <a:ln w="50800">
             <a:solidFill>
               <a:srgbClr val="D6336C"/>
             </a:solidFill>
+            <a:tailEnd type="triangle" w="lg" len="lg"/>
           </a:ln>
         </p:spPr>
         <p:style>
@@ -5033,87 +5034,16 @@
           </a:fontRef>
         </p:style>
       </p:cxnSp>
-      <p:cxnSp>
-        <p:nvCxnSpPr>
-          <p:cNvPr id="43" name="Connector 42"/>
-          <p:cNvCxnSpPr/>
-          <p:nvPr/>
-        </p:nvCxnSpPr>
-        <p:spPr>
-          <a:xfrm flipH="1">
-            <a:off x="4494276" y="640080"/>
-            <a:ext cx="2889504" cy="0"/>
-          </a:xfrm>
-          <a:prstGeom prst="line">
-            <a:avLst/>
-          </a:prstGeom>
-          <a:ln w="57150">
-            <a:solidFill>
-              <a:srgbClr val="D6336C"/>
-            </a:solidFill>
-          </a:ln>
-        </p:spPr>
-        <p:style>
-          <a:lnRef idx="2">
-            <a:schemeClr val="accent1"/>
-          </a:lnRef>
-          <a:fillRef idx="0">
-            <a:schemeClr val="accent1"/>
-          </a:fillRef>
-          <a:effectRef idx="1">
-            <a:schemeClr val="accent1"/>
-          </a:effectRef>
-          <a:fontRef idx="minor">
-            <a:schemeClr val="tx1"/>
-          </a:fontRef>
-        </p:style>
-      </p:cxnSp>
-      <p:cxnSp>
-        <p:nvCxnSpPr>
-          <p:cNvPr id="44" name="Connector 43"/>
-          <p:cNvCxnSpPr/>
-          <p:nvPr/>
-        </p:nvCxnSpPr>
-        <p:spPr>
-          <a:xfrm>
-            <a:off x="4494276" y="640080"/>
-            <a:ext cx="0" cy="502920"/>
-          </a:xfrm>
-          <a:prstGeom prst="line">
-            <a:avLst/>
-          </a:prstGeom>
-          <a:ln w="57150">
-            <a:solidFill>
-              <a:srgbClr val="D6336C"/>
-            </a:solidFill>
-            <a:tailEnd type="triangle" w="lg" len="lg"/>
-          </a:ln>
-        </p:spPr>
-        <p:style>
-          <a:lnRef idx="2">
-            <a:schemeClr val="accent1"/>
-          </a:lnRef>
-          <a:fillRef idx="0">
-            <a:schemeClr val="accent1"/>
-          </a:fillRef>
-          <a:effectRef idx="1">
-            <a:schemeClr val="accent1"/>
-          </a:effectRef>
-          <a:fontRef idx="minor">
-            <a:schemeClr val="tx1"/>
-          </a:fontRef>
-        </p:style>
-      </p:cxnSp>
-      <p:sp>
-        <p:nvSpPr>
-          <p:cNvPr id="45" name="TextBox 44"/>
+      <p:sp>
+        <p:nvSpPr>
+          <p:cNvPr id="43" name="TextBox 42"/>
           <p:cNvSpPr txBox="1"/>
           <p:nvPr/>
         </p:nvSpPr>
         <p:spPr>
           <a:xfrm>
-            <a:off x="3561588" y="228599"/>
-            <a:ext cx="4754880" cy="292608"/>
+            <a:off x="5733288" y="4434840"/>
+            <a:ext cx="640080" cy="274320"/>
           </a:xfrm>
           <a:prstGeom prst="rect">
             <a:avLst/>
@@ -5128,27 +5058,27 @@
           <a:p>
             <a:pPr algn="ctr"/>
             <a:r>
-              <a:rPr sz="1300" b="1" i="1">
+              <a:rPr sz="1000" b="1" i="1">
                 <a:solidFill>
                   <a:srgbClr val="D6336C"/>
                 </a:solidFill>
                 <a:latin typeface="Comic Sans MS"/>
               </a:rPr>
-              <a:t>↺  validator → generation:  keep rewriting the variant until it passes</a:t>
-            </a:r>
-          </a:p>
-        </p:txBody>
-      </p:sp>
-      <p:sp>
-        <p:nvSpPr>
-          <p:cNvPr id="46" name="TextBox 45"/>
+              <a:t>↺  regenerate</a:t>
+            </a:r>
+          </a:p>
+        </p:txBody>
+      </p:sp>
+      <p:sp>
+        <p:nvSpPr>
+          <p:cNvPr id="44" name="TextBox 43"/>
           <p:cNvSpPr txBox="1"/>
           <p:nvPr/>
         </p:nvSpPr>
         <p:spPr>
           <a:xfrm>
-            <a:off x="7018020" y="868680"/>
-            <a:ext cx="731520" cy="228600"/>
+            <a:off x="5733288" y="4828032"/>
+            <a:ext cx="640080" cy="274320"/>
           </a:xfrm>
           <a:prstGeom prst="rect">
             <a:avLst/>
@@ -5163,61 +5093,26 @@
           <a:p>
             <a:pPr algn="ctr"/>
             <a:r>
-              <a:rPr sz="1100" b="1" i="0">
+              <a:rPr sz="900" b="0" i="1">
                 <a:solidFill>
                   <a:srgbClr val="D6336C"/>
                 </a:solidFill>
                 <a:latin typeface="Comic Sans MS"/>
               </a:rPr>
-              <a:t>fail</a:t>
-            </a:r>
-          </a:p>
-        </p:txBody>
-      </p:sp>
-      <p:sp>
-        <p:nvSpPr>
-          <p:cNvPr id="47" name="TextBox 46"/>
-          <p:cNvSpPr txBox="1"/>
-          <p:nvPr/>
-        </p:nvSpPr>
-        <p:spPr>
-          <a:xfrm>
-            <a:off x="4037076" y="868680"/>
-            <a:ext cx="914400" cy="228600"/>
-          </a:xfrm>
-          <a:prstGeom prst="rect">
-            <a:avLst/>
-          </a:prstGeom>
-          <a:noFill/>
-        </p:spPr>
-        <p:txBody>
-          <a:bodyPr wrap="square">
-            <a:spAutoFit/>
-          </a:bodyPr>
-          <a:lstStyle/>
-          <a:p>
-            <a:pPr algn="ctr"/>
-            <a:r>
-              <a:rPr sz="1100" b="1" i="0">
-                <a:solidFill>
-                  <a:srgbClr val="D6336C"/>
-                </a:solidFill>
-                <a:latin typeface="Comic Sans MS"/>
-              </a:rPr>
-              <a:t>regen</a:t>
-            </a:r>
-          </a:p>
-        </p:txBody>
-      </p:sp>
-      <p:sp>
-        <p:nvSpPr>
-          <p:cNvPr id="48" name="Rounded Rectangle 47"/>
+              <a:t>if check fails</a:t>
+            </a:r>
+          </a:p>
+        </p:txBody>
+      </p:sp>
+      <p:sp>
+        <p:nvSpPr>
+          <p:cNvPr id="45" name="Rounded Rectangle 44"/>
           <p:cNvSpPr/>
           <p:nvPr/>
         </p:nvSpPr>
         <p:spPr>
           <a:xfrm>
-            <a:off x="182880" y="6172200"/>
+            <a:off x="182880" y="6126480"/>
             <a:ext cx="11795760" cy="502920"/>
           </a:xfrm>
           <a:prstGeom prst="roundRect">

</xml_diff>